<commit_message>
Simplify presentation cover to project title
</commit_message>
<xml_diff>
--- a/presentation/ethereum_network_analysis.pptx
+++ b/presentation/ethereum_network_analysis.pptx
@@ -10866,83 +10866,6 @@
           </a:p>
         </p:txBody>
       </p:sp>
-      <p:sp>
-        <p:nvSpPr>
-          <p:cNvPr id="3" name="Subtitle 2"/>
-          <p:cNvSpPr>
-            <a:spLocks noGrp="1"/>
-          </p:cNvSpPr>
-          <p:nvPr>
-            <p:ph type="subTitle" idx="1"/>
-            <p:custDataLst>
-              <p:tags r:id="rId3"/>
-            </p:custDataLst>
-          </p:nvPr>
-        </p:nvSpPr>
-        <p:spPr>
-          <a:xfrm>
-            <a:off x="6164580" y="3718560"/>
-            <a:ext cx="2971800" cy="1537990"/>
-          </a:xfrm>
-        </p:spPr>
-        <p:txBody>
-          <a:bodyPr>
-            <a:noAutofit/>
-          </a:bodyPr>
-          <a:lstStyle/>
-          <a:p>
-            <a:pPr algn="l"/>
-            <a:r>
-              <a:rPr lang="en-US" sz="2200" b="1" i="1" dirty="0" smtClean="0">
-                <a:latin typeface="AA-GALAXY-Bold" pitchFamily="2" charset="0"/>
-                <a:cs typeface="AA-GALAXY-Bold" pitchFamily="2" charset="0"/>
-              </a:rPr>
-              <a:t>Name: Mohamed </a:t>
-            </a:r>
-          </a:p>
-          <a:p>
-            <a:pPr algn="l"/>
-            <a:r>
-              <a:rPr lang="en-US" sz="2200" b="1" i="1" dirty="0" err="1" smtClean="0">
-                <a:latin typeface="AA-GALAXY-Bold" pitchFamily="2" charset="0"/>
-                <a:cs typeface="AA-GALAXY-Bold" pitchFamily="2" charset="0"/>
-              </a:rPr>
-              <a:t>Zoher</a:t>
-            </a:r>
-            <a:r>
-              <a:rPr lang="en-US" sz="2200" b="1" i="1" dirty="0" smtClean="0">
-                <a:latin typeface="AA-GALAXY-Bold" pitchFamily="2" charset="0"/>
-                <a:cs typeface="AA-GALAXY-Bold" pitchFamily="2" charset="0"/>
-              </a:rPr>
-              <a:t>   </a:t>
-            </a:r>
-          </a:p>
-          <a:p>
-            <a:pPr algn="l"/>
-            <a:r>
-              <a:rPr lang="en-US" sz="2200" b="1" i="1" dirty="0" smtClean="0">
-                <a:latin typeface="AA-GALAXY-Bold" pitchFamily="2" charset="0"/>
-                <a:cs typeface="AA-GALAXY-Bold" pitchFamily="2" charset="0"/>
-              </a:rPr>
-              <a:t>Mohamed</a:t>
-            </a:r>
-          </a:p>
-          <a:p>
-            <a:pPr algn="l"/>
-            <a:r>
-              <a:rPr lang="en-US" sz="2200" b="1" i="1" dirty="0" smtClean="0">
-                <a:latin typeface="AA-GALAXY-Bold" pitchFamily="2" charset="0"/>
-                <a:cs typeface="AA-GALAXY-Bold" pitchFamily="2" charset="0"/>
-              </a:rPr>
-              <a:t>ID: </a:t>
-            </a:r>
-            <a:endParaRPr lang="en-US" sz="2200" b="1" i="1" dirty="0">
-              <a:latin typeface="AA-GALAXY-Bold" pitchFamily="2" charset="0"/>
-              <a:cs typeface="AA-GALAXY-Bold" pitchFamily="2" charset="0"/>
-            </a:endParaRPr>
-          </a:p>
-        </p:txBody>
-      </p:sp>
       <p:pic>
         <p:nvPicPr>
           <p:cNvPr id="4" name="Picture 3"/>
@@ -11051,83 +10974,6 @@
           </a:sp3d>
         </p:spPr>
       </p:pic>
-      <p:sp>
-        <p:nvSpPr>
-          <p:cNvPr id="6" name="TextBox 5"/>
-          <p:cNvSpPr txBox="1"/>
-          <p:nvPr/>
-        </p:nvSpPr>
-        <p:spPr>
-          <a:xfrm>
-            <a:off x="1478280" y="3810000"/>
-            <a:ext cx="3017520" cy="1446550"/>
-          </a:xfrm>
-          <a:prstGeom prst="rect">
-            <a:avLst/>
-          </a:prstGeom>
-          <a:noFill/>
-        </p:spPr>
-        <p:txBody>
-          <a:bodyPr wrap="square" rtlCol="0">
-            <a:spAutoFit/>
-          </a:bodyPr>
-          <a:lstStyle/>
-          <a:p>
-            <a:r>
-              <a:rPr lang="en-US" sz="2200" b="1" i="1" dirty="0" smtClean="0">
-                <a:latin typeface="AA-GALAXY-Bold" pitchFamily="2" charset="0"/>
-                <a:cs typeface="AA-GALAXY-Bold" pitchFamily="2" charset="0"/>
-              </a:rPr>
-              <a:t>Name: </a:t>
-            </a:r>
-            <a:r>
-              <a:rPr lang="en-US" sz="2200" b="1" i="1" dirty="0" err="1" smtClean="0">
-                <a:latin typeface="AA-GALAXY-Bold" pitchFamily="2" charset="0"/>
-                <a:cs typeface="AA-GALAXY-Bold" pitchFamily="2" charset="0"/>
-              </a:rPr>
-              <a:t>Abdelrahman</a:t>
-            </a:r>
-            <a:r>
-              <a:rPr lang="en-US" sz="2200" b="1" i="1" dirty="0" smtClean="0">
-                <a:latin typeface="AA-GALAXY-Bold" pitchFamily="2" charset="0"/>
-                <a:cs typeface="AA-GALAXY-Bold" pitchFamily="2" charset="0"/>
-              </a:rPr>
-              <a:t> Mohamed  </a:t>
-            </a:r>
-            <a:r>
-              <a:rPr lang="en-US" sz="2200" b="1" i="1" dirty="0" err="1" smtClean="0">
-                <a:latin typeface="AA-GALAXY-Bold" pitchFamily="2" charset="0"/>
-                <a:cs typeface="AA-GALAXY-Bold" pitchFamily="2" charset="0"/>
-              </a:rPr>
-              <a:t>Abdelfattah</a:t>
-            </a:r>
-            <a:endParaRPr lang="en-US" sz="2200" b="1" i="1" dirty="0" smtClean="0">
-              <a:latin typeface="AA-GALAXY-Bold" pitchFamily="2" charset="0"/>
-              <a:cs typeface="AA-GALAXY-Bold" pitchFamily="2" charset="0"/>
-            </a:endParaRPr>
-          </a:p>
-          <a:p>
-            <a:r>
-              <a:rPr lang="en-US" sz="2200" b="1" i="1" dirty="0">
-                <a:latin typeface="AA-GALAXY-Bold" pitchFamily="2" charset="0"/>
-                <a:cs typeface="AA-GALAXY-Bold" pitchFamily="2" charset="0"/>
-              </a:rPr>
-              <a:t>I</a:t>
-            </a:r>
-            <a:r>
-              <a:rPr lang="en-US" sz="2200" b="1" i="1" dirty="0" smtClean="0">
-                <a:latin typeface="AA-GALAXY-Bold" pitchFamily="2" charset="0"/>
-                <a:cs typeface="AA-GALAXY-Bold" pitchFamily="2" charset="0"/>
-              </a:rPr>
-              <a:t>D: </a:t>
-            </a:r>
-            <a:endParaRPr lang="en-US" sz="2200" b="1" i="1" dirty="0">
-              <a:latin typeface="AA-GALAXY-Bold" pitchFamily="2" charset="0"/>
-              <a:cs typeface="AA-GALAXY-Bold" pitchFamily="2" charset="0"/>
-            </a:endParaRPr>
-          </a:p>
-        </p:txBody>
-      </p:sp>
     </p:spTree>
     <p:custDataLst>
       <p:tags r:id="rId1"/>

</xml_diff>

<commit_message>
Remove portrait images from presentation cover
</commit_message>
<xml_diff>
--- a/presentation/ethereum_network_analysis.pptx
+++ b/presentation/ethereum_network_analysis.pptx
@@ -10866,114 +10866,6 @@
           </a:p>
         </p:txBody>
       </p:sp>
-      <p:pic>
-        <p:nvPicPr>
-          <p:cNvPr id="4" name="Picture 3"/>
-          <p:cNvPicPr>
-            <a:picLocks noChangeAspect="1"/>
-          </p:cNvPicPr>
-          <p:nvPr/>
-        </p:nvPicPr>
-        <p:blipFill>
-          <a:blip r:embed="rId6" cstate="email">
-            <a:extLst>
-              <a:ext uri="{28A0092B-C50C-407E-A947-70E740481C1C}">
-                <a14:useLocalDpi xmlns:a14="http://schemas.microsoft.com/office/drawing/2010/main" val="0"/>
-              </a:ext>
-            </a:extLst>
-          </a:blip>
-          <a:stretch>
-            <a:fillRect/>
-          </a:stretch>
-        </p:blipFill>
-        <p:spPr>
-          <a:xfrm>
-            <a:off x="1836420" y="533400"/>
-            <a:ext cx="2400300" cy="3200400"/>
-          </a:xfrm>
-          <a:prstGeom prst="ellipse">
-            <a:avLst/>
-          </a:prstGeom>
-          <a:ln w="63500" cap="rnd">
-            <a:solidFill>
-              <a:srgbClr val="333333"/>
-            </a:solidFill>
-          </a:ln>
-          <a:effectLst>
-            <a:outerShdw blurRad="381000" dist="292100" dir="5400000" sx="-80000" sy="-18000" rotWithShape="0">
-              <a:srgbClr val="000000">
-                <a:alpha val="22000"/>
-              </a:srgbClr>
-            </a:outerShdw>
-          </a:effectLst>
-          <a:scene3d>
-            <a:camera prst="orthographicFront"/>
-            <a:lightRig rig="contrasting" dir="t">
-              <a:rot lat="0" lon="0" rev="3000000"/>
-            </a:lightRig>
-          </a:scene3d>
-          <a:sp3d contourW="7620">
-            <a:bevelT w="95250" h="31750"/>
-            <a:contourClr>
-              <a:srgbClr val="333333"/>
-            </a:contourClr>
-          </a:sp3d>
-        </p:spPr>
-      </p:pic>
-      <p:pic>
-        <p:nvPicPr>
-          <p:cNvPr id="5" name="Picture 4"/>
-          <p:cNvPicPr>
-            <a:picLocks noChangeAspect="1"/>
-          </p:cNvPicPr>
-          <p:nvPr/>
-        </p:nvPicPr>
-        <p:blipFill>
-          <a:blip r:embed="rId7" cstate="email">
-            <a:extLst>
-              <a:ext uri="{28A0092B-C50C-407E-A947-70E740481C1C}">
-                <a14:useLocalDpi xmlns:a14="http://schemas.microsoft.com/office/drawing/2010/main" val="0"/>
-              </a:ext>
-            </a:extLst>
-          </a:blip>
-          <a:stretch>
-            <a:fillRect/>
-          </a:stretch>
-        </p:blipFill>
-        <p:spPr>
-          <a:xfrm>
-            <a:off x="6019800" y="609601"/>
-            <a:ext cx="2979205" cy="3055620"/>
-          </a:xfrm>
-          <a:prstGeom prst="ellipse">
-            <a:avLst/>
-          </a:prstGeom>
-          <a:ln w="63500" cap="rnd">
-            <a:solidFill>
-              <a:srgbClr val="333333"/>
-            </a:solidFill>
-          </a:ln>
-          <a:effectLst>
-            <a:outerShdw blurRad="381000" dist="292100" dir="5400000" sx="-80000" sy="-18000" rotWithShape="0">
-              <a:srgbClr val="000000">
-                <a:alpha val="22000"/>
-              </a:srgbClr>
-            </a:outerShdw>
-          </a:effectLst>
-          <a:scene3d>
-            <a:camera prst="orthographicFront"/>
-            <a:lightRig rig="contrasting" dir="t">
-              <a:rot lat="0" lon="0" rev="3000000"/>
-            </a:lightRig>
-          </a:scene3d>
-          <a:sp3d contourW="7620">
-            <a:bevelT w="95250" h="31750"/>
-            <a:contourClr>
-              <a:srgbClr val="333333"/>
-            </a:contourClr>
-          </a:sp3d>
-        </p:spPr>
-      </p:pic>
     </p:spTree>
     <p:custDataLst>
       <p:tags r:id="rId1"/>

</xml_diff>